<commit_message>
Small update to the PPT
</commit_message>
<xml_diff>
--- a/GPP_ZombieAI_DelieWout_2DAE19.pptx
+++ b/GPP_ZombieAI_DelieWout_2DAE19.pptx
@@ -5,7 +5,7 @@
     <p:sldMasterId id="2147483648" r:id="rId4"/>
   </p:sldMasterIdLst>
   <p:notesMasterIdLst>
-    <p:notesMasterId r:id="rId12"/>
+    <p:notesMasterId r:id="rId11"/>
   </p:notesMasterIdLst>
   <p:sldIdLst>
     <p:sldId id="256" r:id="rId5"/>
@@ -14,7 +14,6 @@
     <p:sldId id="258" r:id="rId8"/>
     <p:sldId id="259" r:id="rId9"/>
     <p:sldId id="262" r:id="rId10"/>
-    <p:sldId id="261" r:id="rId11"/>
   </p:sldIdLst>
   <p:sldSz cx="12192000" cy="6858000"/>
   <p:notesSz cx="6858000" cy="9144000"/>
@@ -4162,9 +4161,8 @@
             </a:pPr>
             <a:r>
               <a:rPr lang="en-US" dirty="0"/>
-              <a:t>When the agent gets bitten or the agent sees an enemy, it will check if there is a gun in the inventory and will shoot the enemy</a:t>
-            </a:r>
-            <a:endParaRPr lang="en-BE" dirty="0"/>
+              <a:t>When the agent gets bitten or the agent sees an enemy, it will check if there is a gun in the inventory and will shoot the enemy.</a:t>
+            </a:r>
           </a:p>
         </p:txBody>
       </p:sp>
@@ -4277,6 +4275,18 @@
             <a:pPr marL="0" indent="0">
               <a:buNone/>
             </a:pPr>
+            <a:endParaRPr lang="en-US" dirty="0"/>
+          </a:p>
+          <a:p>
+            <a:pPr marL="0" indent="0">
+              <a:buNone/>
+            </a:pPr>
+            <a:endParaRPr lang="en-US" dirty="0"/>
+          </a:p>
+          <a:p>
+            <a:pPr marL="0" indent="0">
+              <a:buNone/>
+            </a:pPr>
             <a:endParaRPr lang="en-BE" i="1" dirty="0">
               <a:solidFill>
                 <a:schemeClr val="bg1">
@@ -4479,8 +4489,197 @@
             </a:r>
             <a:r>
               <a:rPr lang="nl-NL" dirty="0"/>
-              <a:t> steering</a:t>
-            </a:r>
+              <a:t> steering.</a:t>
+            </a:r>
+          </a:p>
+          <a:p>
+            <a:pPr marL="0" indent="0">
+              <a:buNone/>
+            </a:pPr>
+            <a:r>
+              <a:rPr lang="nl-NL" dirty="0" err="1"/>
+              <a:t>When</a:t>
+            </a:r>
+            <a:r>
+              <a:rPr lang="nl-NL" dirty="0"/>
+              <a:t> </a:t>
+            </a:r>
+            <a:r>
+              <a:rPr lang="nl-NL" dirty="0" err="1"/>
+              <a:t>an</a:t>
+            </a:r>
+            <a:r>
+              <a:rPr lang="nl-NL" dirty="0"/>
+              <a:t> object is found </a:t>
+            </a:r>
+            <a:r>
+              <a:rPr lang="nl-NL" dirty="0" err="1"/>
+              <a:t>that</a:t>
+            </a:r>
+            <a:r>
+              <a:rPr lang="nl-NL" dirty="0"/>
+              <a:t> is </a:t>
+            </a:r>
+            <a:r>
+              <a:rPr lang="nl-NL" dirty="0" err="1"/>
+              <a:t>not</a:t>
+            </a:r>
+            <a:r>
+              <a:rPr lang="nl-NL" dirty="0"/>
+              <a:t> </a:t>
+            </a:r>
+            <a:r>
+              <a:rPr lang="nl-NL" dirty="0" err="1"/>
+              <a:t>garbage</a:t>
+            </a:r>
+            <a:r>
+              <a:rPr lang="nl-NL" dirty="0"/>
+              <a:t> </a:t>
+            </a:r>
+            <a:r>
+              <a:rPr lang="nl-NL" dirty="0" err="1"/>
+              <a:t>it</a:t>
+            </a:r>
+            <a:r>
+              <a:rPr lang="nl-NL" dirty="0"/>
+              <a:t> </a:t>
+            </a:r>
+            <a:r>
+              <a:rPr lang="nl-NL" dirty="0" err="1"/>
+              <a:t>will</a:t>
+            </a:r>
+            <a:r>
+              <a:rPr lang="nl-NL" dirty="0"/>
+              <a:t> run </a:t>
+            </a:r>
+            <a:r>
+              <a:rPr lang="nl-NL" dirty="0" err="1"/>
+              <a:t>towards</a:t>
+            </a:r>
+            <a:r>
+              <a:rPr lang="nl-NL" dirty="0"/>
+              <a:t> </a:t>
+            </a:r>
+            <a:r>
+              <a:rPr lang="nl-NL" dirty="0" err="1"/>
+              <a:t>it</a:t>
+            </a:r>
+            <a:r>
+              <a:rPr lang="nl-NL" dirty="0"/>
+              <a:t> </a:t>
+            </a:r>
+            <a:r>
+              <a:rPr lang="nl-NL" dirty="0" err="1"/>
+              <a:t>and</a:t>
+            </a:r>
+            <a:r>
+              <a:rPr lang="nl-NL" dirty="0"/>
+              <a:t> </a:t>
+            </a:r>
+            <a:r>
+              <a:rPr lang="nl-NL" dirty="0" err="1"/>
+              <a:t>pick</a:t>
+            </a:r>
+            <a:r>
+              <a:rPr lang="nl-NL" dirty="0"/>
+              <a:t> </a:t>
+            </a:r>
+            <a:r>
+              <a:rPr lang="nl-NL" dirty="0" err="1"/>
+              <a:t>it</a:t>
+            </a:r>
+            <a:r>
+              <a:rPr lang="nl-NL" dirty="0"/>
+              <a:t> up</a:t>
+            </a:r>
+          </a:p>
+          <a:p>
+            <a:pPr marL="0" indent="0">
+              <a:buNone/>
+            </a:pPr>
+            <a:r>
+              <a:rPr lang="nl-NL" dirty="0" err="1"/>
+              <a:t>When</a:t>
+            </a:r>
+            <a:r>
+              <a:rPr lang="nl-NL" dirty="0"/>
+              <a:t> </a:t>
+            </a:r>
+            <a:r>
+              <a:rPr lang="nl-NL" dirty="0" err="1"/>
+              <a:t>the</a:t>
+            </a:r>
+            <a:r>
+              <a:rPr lang="nl-NL" dirty="0"/>
+              <a:t> agent </a:t>
+            </a:r>
+            <a:r>
+              <a:rPr lang="nl-NL" dirty="0" err="1"/>
+              <a:t>percepts</a:t>
+            </a:r>
+            <a:r>
+              <a:rPr lang="nl-NL" dirty="0"/>
+              <a:t> </a:t>
+            </a:r>
+            <a:r>
+              <a:rPr lang="nl-NL" dirty="0" err="1"/>
+              <a:t>the</a:t>
+            </a:r>
+            <a:r>
+              <a:rPr lang="nl-NL" dirty="0"/>
+              <a:t> </a:t>
+            </a:r>
+            <a:r>
+              <a:rPr lang="nl-NL" dirty="0" err="1"/>
+              <a:t>nearest</a:t>
+            </a:r>
+            <a:r>
+              <a:rPr lang="nl-NL" dirty="0"/>
+              <a:t> purgezone, </a:t>
+            </a:r>
+            <a:r>
+              <a:rPr lang="nl-NL" dirty="0" err="1"/>
+              <a:t>it</a:t>
+            </a:r>
+            <a:r>
+              <a:rPr lang="nl-NL" dirty="0"/>
+              <a:t> </a:t>
+            </a:r>
+            <a:r>
+              <a:rPr lang="nl-NL" dirty="0" err="1"/>
+              <a:t>flees</a:t>
+            </a:r>
+            <a:r>
+              <a:rPr lang="nl-NL" dirty="0"/>
+              <a:t> </a:t>
+            </a:r>
+            <a:r>
+              <a:rPr lang="nl-NL" dirty="0" err="1"/>
+              <a:t>away</a:t>
+            </a:r>
+            <a:r>
+              <a:rPr lang="nl-NL" dirty="0"/>
+              <a:t> </a:t>
+            </a:r>
+            <a:r>
+              <a:rPr lang="nl-NL" dirty="0" err="1"/>
+              <a:t>from</a:t>
+            </a:r>
+            <a:r>
+              <a:rPr lang="nl-NL" dirty="0"/>
+              <a:t> it.</a:t>
+            </a:r>
+          </a:p>
+          <a:p>
+            <a:pPr marL="0" indent="0">
+              <a:buNone/>
+            </a:pPr>
+            <a:endParaRPr lang="nl-NL" dirty="0"/>
+          </a:p>
+          <a:p>
+            <a:pPr marL="0" indent="0">
+              <a:buNone/>
+            </a:pPr>
             <a:endParaRPr lang="en-BE" dirty="0"/>
           </a:p>
         </p:txBody>
@@ -4590,31 +4789,195 @@
       </p:sp>
       <p:sp>
         <p:nvSpPr>
-          <p:cNvPr id="4" name="TextBox 3">
-            <a:extLst>
-              <a:ext uri="{FF2B5EF4-FFF2-40B4-BE49-F238E27FC236}">
-                <a16:creationId xmlns:a16="http://schemas.microsoft.com/office/drawing/2014/main" id="{064BC435-7534-33BF-5194-8555DA146825}"/>
-              </a:ext>
-            </a:extLst>
-          </p:cNvPr>
-          <p:cNvSpPr txBox="1"/>
+          <p:cNvPr id="5" name="Content Placeholder 2">
+            <a:extLst>
+              <a:ext uri="{FF2B5EF4-FFF2-40B4-BE49-F238E27FC236}">
+                <a16:creationId xmlns:a16="http://schemas.microsoft.com/office/drawing/2014/main" id="{5910C215-3665-9083-CBCA-E1681B709574}"/>
+              </a:ext>
+            </a:extLst>
+          </p:cNvPr>
+          <p:cNvSpPr txBox="1">
+            <a:spLocks/>
+          </p:cNvSpPr>
           <p:nvPr/>
         </p:nvSpPr>
         <p:spPr>
           <a:xfrm>
-            <a:off x="838200" y="1729333"/>
-            <a:ext cx="10609250" cy="369332"/>
+            <a:off x="990600" y="1978025"/>
+            <a:ext cx="10515600" cy="4351338"/>
           </a:xfrm>
           <a:prstGeom prst="rect">
             <a:avLst/>
           </a:prstGeom>
-          <a:noFill/>
         </p:spPr>
         <p:txBody>
-          <a:bodyPr wrap="square" rtlCol="0">
-            <a:spAutoFit/>
+          <a:bodyPr vert="horz" lIns="91440" tIns="45720" rIns="91440" bIns="45720" rtlCol="0">
+            <a:normAutofit/>
           </a:bodyPr>
-          <a:lstStyle/>
+          <a:lstStyle>
+            <a:lvl1pPr marL="228600" indent="-228600" algn="l" defTabSz="914400" rtl="0" eaLnBrk="1" latinLnBrk="0" hangingPunct="1">
+              <a:lnSpc>
+                <a:spcPct val="90000"/>
+              </a:lnSpc>
+              <a:spcBef>
+                <a:spcPts val="1000"/>
+              </a:spcBef>
+              <a:buFont typeface="Arial" panose="020B0604020202020204" pitchFamily="34" charset="0"/>
+              <a:buChar char="•"/>
+              <a:defRPr sz="2800" kern="1200">
+                <a:solidFill>
+                  <a:schemeClr val="tx1"/>
+                </a:solidFill>
+                <a:latin typeface="+mn-lt"/>
+                <a:ea typeface="+mn-ea"/>
+                <a:cs typeface="+mn-cs"/>
+              </a:defRPr>
+            </a:lvl1pPr>
+            <a:lvl2pPr marL="685800" indent="-228600" algn="l" defTabSz="914400" rtl="0" eaLnBrk="1" latinLnBrk="0" hangingPunct="1">
+              <a:lnSpc>
+                <a:spcPct val="90000"/>
+              </a:lnSpc>
+              <a:spcBef>
+                <a:spcPts val="500"/>
+              </a:spcBef>
+              <a:buFont typeface="Arial" panose="020B0604020202020204" pitchFamily="34" charset="0"/>
+              <a:buChar char="•"/>
+              <a:defRPr sz="2400" kern="1200">
+                <a:solidFill>
+                  <a:schemeClr val="tx1"/>
+                </a:solidFill>
+                <a:latin typeface="+mn-lt"/>
+                <a:ea typeface="+mn-ea"/>
+                <a:cs typeface="+mn-cs"/>
+              </a:defRPr>
+            </a:lvl2pPr>
+            <a:lvl3pPr marL="1143000" indent="-228600" algn="l" defTabSz="914400" rtl="0" eaLnBrk="1" latinLnBrk="0" hangingPunct="1">
+              <a:lnSpc>
+                <a:spcPct val="90000"/>
+              </a:lnSpc>
+              <a:spcBef>
+                <a:spcPts val="500"/>
+              </a:spcBef>
+              <a:buFont typeface="Arial" panose="020B0604020202020204" pitchFamily="34" charset="0"/>
+              <a:buChar char="•"/>
+              <a:defRPr sz="2000" kern="1200">
+                <a:solidFill>
+                  <a:schemeClr val="tx1"/>
+                </a:solidFill>
+                <a:latin typeface="+mn-lt"/>
+                <a:ea typeface="+mn-ea"/>
+                <a:cs typeface="+mn-cs"/>
+              </a:defRPr>
+            </a:lvl3pPr>
+            <a:lvl4pPr marL="1600200" indent="-228600" algn="l" defTabSz="914400" rtl="0" eaLnBrk="1" latinLnBrk="0" hangingPunct="1">
+              <a:lnSpc>
+                <a:spcPct val="90000"/>
+              </a:lnSpc>
+              <a:spcBef>
+                <a:spcPts val="500"/>
+              </a:spcBef>
+              <a:buFont typeface="Arial" panose="020B0604020202020204" pitchFamily="34" charset="0"/>
+              <a:buChar char="•"/>
+              <a:defRPr sz="1800" kern="1200">
+                <a:solidFill>
+                  <a:schemeClr val="tx1"/>
+                </a:solidFill>
+                <a:latin typeface="+mn-lt"/>
+                <a:ea typeface="+mn-ea"/>
+                <a:cs typeface="+mn-cs"/>
+              </a:defRPr>
+            </a:lvl4pPr>
+            <a:lvl5pPr marL="2057400" indent="-228600" algn="l" defTabSz="914400" rtl="0" eaLnBrk="1" latinLnBrk="0" hangingPunct="1">
+              <a:lnSpc>
+                <a:spcPct val="90000"/>
+              </a:lnSpc>
+              <a:spcBef>
+                <a:spcPts val="500"/>
+              </a:spcBef>
+              <a:buFont typeface="Arial" panose="020B0604020202020204" pitchFamily="34" charset="0"/>
+              <a:buChar char="•"/>
+              <a:defRPr sz="1800" kern="1200">
+                <a:solidFill>
+                  <a:schemeClr val="tx1"/>
+                </a:solidFill>
+                <a:latin typeface="+mn-lt"/>
+                <a:ea typeface="+mn-ea"/>
+                <a:cs typeface="+mn-cs"/>
+              </a:defRPr>
+            </a:lvl5pPr>
+            <a:lvl6pPr marL="2514600" indent="-228600" algn="l" defTabSz="914400" rtl="0" eaLnBrk="1" latinLnBrk="0" hangingPunct="1">
+              <a:lnSpc>
+                <a:spcPct val="90000"/>
+              </a:lnSpc>
+              <a:spcBef>
+                <a:spcPts val="500"/>
+              </a:spcBef>
+              <a:buFont typeface="Arial" panose="020B0604020202020204" pitchFamily="34" charset="0"/>
+              <a:buChar char="•"/>
+              <a:defRPr sz="1800" kern="1200">
+                <a:solidFill>
+                  <a:schemeClr val="tx1"/>
+                </a:solidFill>
+                <a:latin typeface="+mn-lt"/>
+                <a:ea typeface="+mn-ea"/>
+                <a:cs typeface="+mn-cs"/>
+              </a:defRPr>
+            </a:lvl6pPr>
+            <a:lvl7pPr marL="2971800" indent="-228600" algn="l" defTabSz="914400" rtl="0" eaLnBrk="1" latinLnBrk="0" hangingPunct="1">
+              <a:lnSpc>
+                <a:spcPct val="90000"/>
+              </a:lnSpc>
+              <a:spcBef>
+                <a:spcPts val="500"/>
+              </a:spcBef>
+              <a:buFont typeface="Arial" panose="020B0604020202020204" pitchFamily="34" charset="0"/>
+              <a:buChar char="•"/>
+              <a:defRPr sz="1800" kern="1200">
+                <a:solidFill>
+                  <a:schemeClr val="tx1"/>
+                </a:solidFill>
+                <a:latin typeface="+mn-lt"/>
+                <a:ea typeface="+mn-ea"/>
+                <a:cs typeface="+mn-cs"/>
+              </a:defRPr>
+            </a:lvl7pPr>
+            <a:lvl8pPr marL="3429000" indent="-228600" algn="l" defTabSz="914400" rtl="0" eaLnBrk="1" latinLnBrk="0" hangingPunct="1">
+              <a:lnSpc>
+                <a:spcPct val="90000"/>
+              </a:lnSpc>
+              <a:spcBef>
+                <a:spcPts val="500"/>
+              </a:spcBef>
+              <a:buFont typeface="Arial" panose="020B0604020202020204" pitchFamily="34" charset="0"/>
+              <a:buChar char="•"/>
+              <a:defRPr sz="1800" kern="1200">
+                <a:solidFill>
+                  <a:schemeClr val="tx1"/>
+                </a:solidFill>
+                <a:latin typeface="+mn-lt"/>
+                <a:ea typeface="+mn-ea"/>
+                <a:cs typeface="+mn-cs"/>
+              </a:defRPr>
+            </a:lvl8pPr>
+            <a:lvl9pPr marL="3886200" indent="-228600" algn="l" defTabSz="914400" rtl="0" eaLnBrk="1" latinLnBrk="0" hangingPunct="1">
+              <a:lnSpc>
+                <a:spcPct val="90000"/>
+              </a:lnSpc>
+              <a:spcBef>
+                <a:spcPts val="500"/>
+              </a:spcBef>
+              <a:buFont typeface="Arial" panose="020B0604020202020204" pitchFamily="34" charset="0"/>
+              <a:buChar char="•"/>
+              <a:defRPr sz="1800" kern="1200">
+                <a:solidFill>
+                  <a:schemeClr val="tx1"/>
+                </a:solidFill>
+                <a:latin typeface="+mn-lt"/>
+                <a:ea typeface="+mn-ea"/>
+                <a:cs typeface="+mn-cs"/>
+              </a:defRPr>
+            </a:lvl9pPr>
+          </a:lstStyle>
           <a:p>
             <a:r>
               <a:rPr lang="nl-NL" dirty="0"/>
@@ -4682,13 +5045,186 @@
             </a:r>
             <a:r>
               <a:rPr lang="nl-NL" dirty="0"/>
-              <a:t> enter </a:t>
+              <a:t> enter it.</a:t>
+            </a:r>
+          </a:p>
+          <a:p>
+            <a:r>
+              <a:rPr lang="nl-NL" dirty="0" err="1"/>
+              <a:t>Tried</a:t>
+            </a:r>
+            <a:r>
+              <a:rPr lang="nl-NL" dirty="0"/>
+              <a:t> </a:t>
+            </a:r>
+            <a:r>
+              <a:rPr lang="nl-NL" dirty="0" err="1"/>
+              <a:t>to</a:t>
+            </a:r>
+            <a:r>
+              <a:rPr lang="nl-NL" dirty="0"/>
+              <a:t> </a:t>
+            </a:r>
+            <a:r>
+              <a:rPr lang="nl-NL" dirty="0" err="1"/>
+              <a:t>implement</a:t>
+            </a:r>
+            <a:r>
+              <a:rPr lang="nl-NL" dirty="0"/>
+              <a:t> a log </a:t>
+            </a:r>
+            <a:r>
+              <a:rPr lang="nl-NL" dirty="0" err="1"/>
+              <a:t>when</a:t>
+            </a:r>
+            <a:r>
+              <a:rPr lang="nl-NL" dirty="0"/>
+              <a:t> </a:t>
+            </a:r>
+            <a:r>
+              <a:rPr lang="nl-NL" dirty="0" err="1"/>
+              <a:t>it</a:t>
+            </a:r>
+            <a:r>
+              <a:rPr lang="nl-NL" dirty="0"/>
+              <a:t> </a:t>
+            </a:r>
+            <a:r>
+              <a:rPr lang="nl-NL" dirty="0" err="1"/>
+              <a:t>finds</a:t>
+            </a:r>
+            <a:r>
+              <a:rPr lang="nl-NL" dirty="0"/>
+              <a:t> a new house but </a:t>
+            </a:r>
+            <a:r>
+              <a:rPr lang="nl-NL" dirty="0" err="1"/>
+              <a:t>it</a:t>
+            </a:r>
+            <a:r>
+              <a:rPr lang="nl-NL" dirty="0"/>
+              <a:t> </a:t>
+            </a:r>
+            <a:r>
+              <a:rPr lang="nl-NL" dirty="0" err="1"/>
+              <a:t>didnt</a:t>
+            </a:r>
+            <a:r>
+              <a:rPr lang="nl-NL" dirty="0"/>
+              <a:t> </a:t>
+            </a:r>
+            <a:r>
+              <a:rPr lang="nl-NL" dirty="0" err="1"/>
+              <a:t>work</a:t>
+            </a:r>
+            <a:r>
+              <a:rPr lang="nl-NL" dirty="0"/>
+              <a:t>, </a:t>
+            </a:r>
+            <a:r>
+              <a:rPr lang="nl-NL" dirty="0" err="1"/>
+              <a:t>so</a:t>
+            </a:r>
+            <a:r>
+              <a:rPr lang="nl-NL" dirty="0"/>
+              <a:t> I </a:t>
+            </a:r>
+            <a:r>
+              <a:rPr lang="nl-NL" dirty="0" err="1"/>
+              <a:t>removed</a:t>
+            </a:r>
+            <a:r>
+              <a:rPr lang="nl-NL" dirty="0"/>
+              <a:t> it.</a:t>
+            </a:r>
+          </a:p>
+          <a:p>
+            <a:r>
+              <a:rPr lang="nl-NL" dirty="0" err="1"/>
+              <a:t>When</a:t>
+            </a:r>
+            <a:r>
+              <a:rPr lang="nl-NL" dirty="0"/>
+              <a:t> </a:t>
+            </a:r>
+            <a:r>
+              <a:rPr lang="nl-NL" dirty="0" err="1"/>
+              <a:t>the</a:t>
+            </a:r>
+            <a:r>
+              <a:rPr lang="nl-NL" dirty="0"/>
+              <a:t> agent </a:t>
+            </a:r>
+            <a:r>
+              <a:rPr lang="nl-NL" dirty="0" err="1"/>
+              <a:t>percepts</a:t>
+            </a:r>
+            <a:r>
+              <a:rPr lang="nl-NL" dirty="0"/>
+              <a:t> </a:t>
+            </a:r>
+            <a:r>
+              <a:rPr lang="nl-NL" dirty="0" err="1"/>
+              <a:t>the</a:t>
+            </a:r>
+            <a:r>
+              <a:rPr lang="nl-NL" dirty="0"/>
+              <a:t> </a:t>
+            </a:r>
+            <a:r>
+              <a:rPr lang="nl-NL" dirty="0" err="1"/>
+              <a:t>nearest</a:t>
+            </a:r>
+            <a:r>
+              <a:rPr lang="nl-NL" dirty="0"/>
+              <a:t> purgezone, </a:t>
+            </a:r>
+            <a:r>
+              <a:rPr lang="nl-NL" dirty="0" err="1"/>
+              <a:t>it</a:t>
+            </a:r>
+            <a:r>
+              <a:rPr lang="nl-NL" dirty="0"/>
+              <a:t> </a:t>
+            </a:r>
+            <a:r>
+              <a:rPr lang="nl-NL" dirty="0" err="1"/>
+              <a:t>flees</a:t>
+            </a:r>
+            <a:r>
+              <a:rPr lang="nl-NL" dirty="0"/>
+              <a:t> </a:t>
+            </a:r>
+            <a:r>
+              <a:rPr lang="nl-NL" dirty="0" err="1"/>
+              <a:t>away</a:t>
+            </a:r>
+            <a:r>
+              <a:rPr lang="nl-NL" dirty="0"/>
+              <a:t> </a:t>
+            </a:r>
+            <a:r>
+              <a:rPr lang="nl-NL" dirty="0" err="1"/>
+              <a:t>from</a:t>
             </a:r>
             <a:r>
               <a:rPr lang="nl-NL"/>
-              <a:t>it.</a:t>
-            </a:r>
+              <a:t> it.</a:t>
+            </a:r>
+          </a:p>
+          <a:p>
+            <a:pPr marL="0" indent="0">
+              <a:buFont typeface="Arial" panose="020B0604020202020204" pitchFamily="34" charset="0"/>
+              <a:buNone/>
+            </a:pPr>
             <a:endParaRPr lang="nl-NL" dirty="0"/>
+          </a:p>
+          <a:p>
+            <a:pPr marL="0" indent="0">
+              <a:buFont typeface="Arial" panose="020B0604020202020204" pitchFamily="34" charset="0"/>
+              <a:buNone/>
+            </a:pPr>
+            <a:endParaRPr lang="en-BE" dirty="0"/>
           </a:p>
         </p:txBody>
       </p:sp>
@@ -4696,109 +5232,6 @@
     <p:extLst>
       <p:ext uri="{BB962C8B-B14F-4D97-AF65-F5344CB8AC3E}">
         <p14:creationId xmlns:p14="http://schemas.microsoft.com/office/powerpoint/2010/main" val="1652142467"/>
-      </p:ext>
-    </p:extLst>
-  </p:cSld>
-  <p:clrMapOvr>
-    <a:masterClrMapping/>
-  </p:clrMapOvr>
-</p:sld>
-</file>
-
-<file path=ppt/slides/slide7.xml><?xml version="1.0" encoding="utf-8"?>
-<p:sld xmlns:a="http://schemas.openxmlformats.org/drawingml/2006/main" xmlns:r="http://schemas.openxmlformats.org/officeDocument/2006/relationships" xmlns:p="http://schemas.openxmlformats.org/presentationml/2006/main">
-  <p:cSld>
-    <p:spTree>
-      <p:nvGrpSpPr>
-        <p:cNvPr id="1" name=""/>
-        <p:cNvGrpSpPr/>
-        <p:nvPr/>
-      </p:nvGrpSpPr>
-      <p:grpSpPr>
-        <a:xfrm>
-          <a:off x="0" y="0"/>
-          <a:ext cx="0" cy="0"/>
-          <a:chOff x="0" y="0"/>
-          <a:chExt cx="0" cy="0"/>
-        </a:xfrm>
-      </p:grpSpPr>
-      <p:sp>
-        <p:nvSpPr>
-          <p:cNvPr id="2" name="Title 1">
-            <a:extLst>
-              <a:ext uri="{FF2B5EF4-FFF2-40B4-BE49-F238E27FC236}">
-                <a16:creationId xmlns:a16="http://schemas.microsoft.com/office/drawing/2014/main" id="{EF6BB071-C63E-40D3-93C6-9F99F27862FE}"/>
-              </a:ext>
-            </a:extLst>
-          </p:cNvPr>
-          <p:cNvSpPr>
-            <a:spLocks noGrp="1"/>
-          </p:cNvSpPr>
-          <p:nvPr>
-            <p:ph type="title"/>
-          </p:nvPr>
-        </p:nvSpPr>
-        <p:spPr/>
-        <p:txBody>
-          <a:bodyPr/>
-          <a:lstStyle/>
-          <a:p>
-            <a:r>
-              <a:rPr lang="en-US"/>
-              <a:t>High Score</a:t>
-            </a:r>
-            <a:endParaRPr lang="en-BE"/>
-          </a:p>
-        </p:txBody>
-      </p:sp>
-      <p:sp>
-        <p:nvSpPr>
-          <p:cNvPr id="3" name="Content Placeholder 2">
-            <a:extLst>
-              <a:ext uri="{FF2B5EF4-FFF2-40B4-BE49-F238E27FC236}">
-                <a16:creationId xmlns:a16="http://schemas.microsoft.com/office/drawing/2014/main" id="{64915428-ACD8-4B22-96DC-2806680ED3AB}"/>
-              </a:ext>
-            </a:extLst>
-          </p:cNvPr>
-          <p:cNvSpPr>
-            <a:spLocks noGrp="1"/>
-          </p:cNvSpPr>
-          <p:nvPr>
-            <p:ph idx="1"/>
-          </p:nvPr>
-        </p:nvSpPr>
-        <p:spPr/>
-        <p:txBody>
-          <a:bodyPr/>
-          <a:lstStyle/>
-          <a:p>
-            <a:pPr marL="0" indent="0">
-              <a:buNone/>
-            </a:pPr>
-            <a:r>
-              <a:rPr lang="en-US">
-                <a:solidFill>
-                  <a:schemeClr val="bg1">
-                    <a:lumMod val="75000"/>
-                  </a:schemeClr>
-                </a:solidFill>
-              </a:rPr>
-              <a:t>Screen shot or list of highest scores</a:t>
-            </a:r>
-            <a:endParaRPr lang="en-BE">
-              <a:solidFill>
-                <a:schemeClr val="bg1">
-                  <a:lumMod val="75000"/>
-                </a:schemeClr>
-              </a:solidFill>
-            </a:endParaRPr>
-          </a:p>
-        </p:txBody>
-      </p:sp>
-    </p:spTree>
-    <p:extLst>
-      <p:ext uri="{BB962C8B-B14F-4D97-AF65-F5344CB8AC3E}">
-        <p14:creationId xmlns:p14="http://schemas.microsoft.com/office/powerpoint/2010/main" val="3423734040"/>
       </p:ext>
     </p:extLst>
   </p:cSld>
@@ -5419,18 +5852,12 @@
 </file>
 
 <file path=customXml/item1.xml><?xml version="1.0" encoding="utf-8"?>
-<p:properties xmlns:p="http://schemas.microsoft.com/office/2006/metadata/properties" xmlns:xsi="http://www.w3.org/2001/XMLSchema-instance" xmlns:pc="http://schemas.microsoft.com/office/infopath/2007/PartnerControls">
-  <documentManagement>
-    <IconOverlay xmlns="http://schemas.microsoft.com/sharepoint/v4" xsi:nil="true"/>
-    <TaxCatchAll xmlns="128482ec-0431-40d5-ab26-89ea2a4f3ccd" xsi:nil="true"/>
-    <m99485b88215436a82099f8287cba0b0 xmlns="128482ec-0431-40d5-ab26-89ea2a4f3ccd">
-      <Terms xmlns="http://schemas.microsoft.com/office/infopath/2007/PartnerControls"/>
-    </m99485b88215436a82099f8287cba0b0>
-    <lcf76f155ced4ddcb4097134ff3c332f xmlns="60eb0cf4-ae2a-4762-800a-cb593b869ecb">
-      <Terms xmlns="http://schemas.microsoft.com/office/infopath/2007/PartnerControls"/>
-    </lcf76f155ced4ddcb4097134ff3c332f>
-  </documentManagement>
-</p:properties>
+<?mso-contentType ?>
+<FormTemplates xmlns="http://schemas.microsoft.com/sharepoint/v3/contenttype/forms">
+  <Display>DocumentLibraryForm</Display>
+  <Edit>DocumentLibraryForm</Edit>
+  <New>DocumentLibraryForm</New>
+</FormTemplates>
 </file>
 
 <file path=customXml/item2.xml><?xml version="1.0" encoding="utf-8"?>
@@ -5707,22 +6134,24 @@
 </file>
 
 <file path=customXml/item3.xml><?xml version="1.0" encoding="utf-8"?>
-<?mso-contentType ?>
-<FormTemplates xmlns="http://schemas.microsoft.com/sharepoint/v3/contenttype/forms">
-  <Display>DocumentLibraryForm</Display>
-  <Edit>DocumentLibraryForm</Edit>
-  <New>DocumentLibraryForm</New>
-</FormTemplates>
+<p:properties xmlns:p="http://schemas.microsoft.com/office/2006/metadata/properties" xmlns:xsi="http://www.w3.org/2001/XMLSchema-instance" xmlns:pc="http://schemas.microsoft.com/office/infopath/2007/PartnerControls">
+  <documentManagement>
+    <IconOverlay xmlns="http://schemas.microsoft.com/sharepoint/v4" xsi:nil="true"/>
+    <TaxCatchAll xmlns="128482ec-0431-40d5-ab26-89ea2a4f3ccd" xsi:nil="true"/>
+    <m99485b88215436a82099f8287cba0b0 xmlns="128482ec-0431-40d5-ab26-89ea2a4f3ccd">
+      <Terms xmlns="http://schemas.microsoft.com/office/infopath/2007/PartnerControls"/>
+    </m99485b88215436a82099f8287cba0b0>
+    <lcf76f155ced4ddcb4097134ff3c332f xmlns="60eb0cf4-ae2a-4762-800a-cb593b869ecb">
+      <Terms xmlns="http://schemas.microsoft.com/office/infopath/2007/PartnerControls"/>
+    </lcf76f155ced4ddcb4097134ff3c332f>
+  </documentManagement>
+</p:properties>
 </file>
 
 <file path=customXml/itemProps1.xml><?xml version="1.0" encoding="utf-8"?>
-<ds:datastoreItem xmlns:ds="http://schemas.openxmlformats.org/officeDocument/2006/customXml" ds:itemID="{B743389A-7EE0-4951-8919-E91DD69E3687}">
+<ds:datastoreItem xmlns:ds="http://schemas.openxmlformats.org/officeDocument/2006/customXml" ds:itemID="{AF8EC6D1-CB19-4400-AD0A-0C75CD884AEA}">
   <ds:schemaRefs>
-    <ds:schemaRef ds:uri="128482ec-0431-40d5-ab26-89ea2a4f3ccd"/>
-    <ds:schemaRef ds:uri="http://schemas.microsoft.com/office/2006/metadata/properties"/>
-    <ds:schemaRef ds:uri="http://schemas.microsoft.com/office/infopath/2007/PartnerControls"/>
-    <ds:schemaRef ds:uri="http://schemas.microsoft.com/sharepoint/v4"/>
-    <ds:schemaRef ds:uri="60eb0cf4-ae2a-4762-800a-cb593b869ecb"/>
+    <ds:schemaRef ds:uri="http://schemas.microsoft.com/sharepoint/v3/contenttype/forms"/>
   </ds:schemaRefs>
 </ds:datastoreItem>
 </file>
@@ -5749,9 +6178,13 @@
 </file>
 
 <file path=customXml/itemProps3.xml><?xml version="1.0" encoding="utf-8"?>
-<ds:datastoreItem xmlns:ds="http://schemas.openxmlformats.org/officeDocument/2006/customXml" ds:itemID="{AF8EC6D1-CB19-4400-AD0A-0C75CD884AEA}">
+<ds:datastoreItem xmlns:ds="http://schemas.openxmlformats.org/officeDocument/2006/customXml" ds:itemID="{B743389A-7EE0-4951-8919-E91DD69E3687}">
   <ds:schemaRefs>
-    <ds:schemaRef ds:uri="http://schemas.microsoft.com/sharepoint/v3/contenttype/forms"/>
+    <ds:schemaRef ds:uri="128482ec-0431-40d5-ab26-89ea2a4f3ccd"/>
+    <ds:schemaRef ds:uri="http://schemas.microsoft.com/office/2006/metadata/properties"/>
+    <ds:schemaRef ds:uri="http://schemas.microsoft.com/office/infopath/2007/PartnerControls"/>
+    <ds:schemaRef ds:uri="http://schemas.microsoft.com/sharepoint/v4"/>
+    <ds:schemaRef ds:uri="60eb0cf4-ae2a-4762-800a-cb593b869ecb"/>
   </ds:schemaRefs>
 </ds:datastoreItem>
 </file>
</xml_diff>